<commit_message>
docs: consolidate and audit CYBERSEC talk package
</commit_message>
<xml_diff>
--- a/outputs/deck/cybersec-2026-ai-samd-compact-optimized.pptx
+++ b/outputs/deck/cybersec-2026-ai-samd-compact-optimized.pptx
@@ -980,7 +980,7 @@
           <a:lstStyle xmlns:a="http://schemas.openxmlformats.org/drawingml/2006/main"/>
           <a:p xmlns:a="http://schemas.openxmlformats.org/drawingml/2006/main">
             <a:r>
-              <a:t>醫療資安也已經不只是 IT 後台問題；當 AI 進入醫療，cyber incident 很快就會變成 care disruption。</a:t>
+              <a:t>醫療資安也已經不只是 IT 後台問題；當 AI 進入醫療，cyber incident 可能直接干擾 clinical care。</a:t>
             </a:r>
           </a:p>
         </p:txBody>
@@ -1190,7 +1190,7 @@
           <a:lstStyle xmlns:a="http://schemas.openxmlformats.org/drawingml/2006/main"/>
           <a:p xmlns:a="http://schemas.openxmlformats.org/drawingml/2006/main">
             <a:r>
-              <a:t>這三件事接起來，才是醫療 AI team 真正能拿去討論、治理、送審、跟客戶溝通的 security language。</a:t>
+              <a:t>NIST 在這裡是共同語言，不是控制清單；AI RMF 講 Govern, Map, Measure, Manage，CSF 可補上資安營運語言。</a:t>
             </a:r>
           </a:p>
         </p:txBody>
@@ -7132,7 +7132,7 @@
                   <a:srgbClr val="F5F7FA"/>
                 </a:solidFill>
               </a:rPr>
-              <a:t>Care continuity</a:t>
+              <a:t>Clinical continuity</a:t>
             </a:r>
           </a:p>
         </p:txBody>
@@ -7190,7 +7190,7 @@
                   <a:srgbClr val="9AA7B8"/>
                 </a:solidFill>
               </a:rPr>
-              <a:t>Cyber incidents become care disruption</a:t>
+              <a:t>Cyber incidents can disrupt care</a:t>
             </a:r>
           </a:p>
         </p:txBody>
@@ -8814,7 +8814,7 @@
                   <a:srgbClr val="FF4D5E"/>
                 </a:solidFill>
               </a:rPr>
-              <a:t>Patch</a:t>
+              <a:t>CVD</a:t>
             </a:r>
           </a:p>
         </p:txBody>
@@ -8911,7 +8911,7 @@
                   <a:srgbClr val="38D7FF"/>
                 </a:solidFill>
               </a:rPr>
-              <a:t>Disclose</a:t>
+              <a:t>Patch</a:t>
             </a:r>
           </a:p>
         </p:txBody>
@@ -9652,7 +9652,7 @@
                   <a:srgbClr val="9BF2FF"/>
                 </a:solidFill>
               </a:rPr>
-              <a:t>Governance language</a:t>
+              <a:t>AI RMF language</a:t>
             </a:r>
           </a:p>
         </p:txBody>
@@ -9801,7 +9801,7 @@
                   <a:srgbClr val="9AA7B8"/>
                 </a:solidFill>
               </a:rPr>
-              <a:t>Protect</a:t>
+              <a:t>Map</a:t>
             </a:r>
           </a:p>
         </p:txBody>
@@ -9892,7 +9892,7 @@
                   <a:srgbClr val="9AA7B8"/>
                 </a:solidFill>
               </a:rPr>
-              <a:t>Recover</a:t>
+              <a:t>Measure / Manage</a:t>
             </a:r>
           </a:p>
         </p:txBody>
@@ -11520,7 +11520,7 @@
                   <a:srgbClr val="F5F7FA"/>
                 </a:solidFill>
               </a:rPr>
-              <a:t>RBAC</a:t>
+              <a:t>Backup</a:t>
             </a:r>
           </a:p>
         </p:txBody>

</xml_diff>